<commit_message>
Split the closing into four slides and tighten formatting
TAC Cadre, Alibis, Company Commander and Questions each get their own
slide, matching both the cadre deck and the September deck. Audited
every slide for identical header, title, fonts, colors, ask-bar and quad
geometry; 16 slides total.

Co-Authored-By: Claude Fable 5.1 <noreply@anthropic.com>
Claude-Session: https://claude.ai/code/session_01XkS1vXPEFpXaWgAq51QnDW
</commit_message>
<xml_diff>
--- a/Class_94_CUB_October_Template.pptx
+++ b/Class_94_CUB_October_Template.pptx
@@ -18,9 +18,12 @@
     <p:sldId id="266" r:id="rId12"/>
     <p:sldId id="267" r:id="rId13"/>
     <p:sldId id="268" r:id="rId14"/>
+    <p:sldId id="269" r:id="rId15"/>
+    <p:sldId id="270" r:id="rId16"/>
+    <p:sldId id="271" r:id="rId17"/>
   </p:sldIdLst>
   <p:notesMasterIdLst>
-    <p:notesMasterId r:id="rId15"/>
+    <p:notesMasterId r:id="rId18"/>
   </p:notesMasterIdLst>
   <p:sldSz cx="12192000" cy="6858000"/>
   <p:notesSz cx="6858000" cy="12192000"/>
@@ -866,7 +869,7 @@
           <a:p>
             <a:r>
               <a:rPr lang="en-US" dirty="0"/>
-              <a:t>4 bullets max per box, about 8 words each. Brief the so-what; don't read the slide. Decisions go on slide 12.</a:t>
+              <a:t>Hand the floor to the TAC cadre. Capture guidance on the Status Tracker.</a:t>
             </a:r>
             <a:endParaRPr lang="en-US" dirty="0"/>
           </a:p>
@@ -890,6 +893,270 @@
             <a:fld id="{F7021451-1387-4CA6-816F-3879F97B5CBC}" type="slidenum">
               <a:rPr lang="en-US"/>
               <a:t>13</a:t>
+            </a:fld>
+            <a:endParaRPr lang="en-US"/>
+          </a:p>
+        </p:txBody>
+      </p:sp>
+    </p:spTree>
+    <p:extLst>
+      <p:ext uri="{BB962C8B-B14F-4D97-AF65-F5344CB8AC3E}">
+        <p14:creationId xmlns:p14="http://schemas.microsoft.com/office/powerpoint/2010/main" val="1024086991"/>
+      </p:ext>
+    </p:extLst>
+  </p:cSld>
+  <p:clrMapOvr>
+    <a:masterClrMapping/>
+  </p:clrMapOvr>
+</p:notes>
+</file>
+
+<file path=ppt/notesSlides/notesSlide14.xml><?xml version="1.0" encoding="utf-8"?>
+<p:notes xmlns:a="http://schemas.openxmlformats.org/drawingml/2006/main" xmlns:r="http://schemas.openxmlformats.org/officeDocument/2006/relationships" xmlns:p="http://schemas.openxmlformats.org/presentationml/2006/main">
+  <p:cSld>
+    <p:spTree>
+      <p:nvGrpSpPr>
+        <p:cNvPr id="1" name=""/>
+        <p:cNvGrpSpPr/>
+        <p:nvPr/>
+      </p:nvGrpSpPr>
+      <p:grpSpPr>
+        <a:xfrm>
+          <a:off x="0" y="0"/>
+          <a:ext cx="0" cy="0"/>
+          <a:chOff x="0" y="0"/>
+          <a:chExt cx="0" cy="0"/>
+        </a:xfrm>
+      </p:grpSpPr>
+      <p:sp>
+        <p:nvSpPr>
+          <p:cNvPr id="2" name="Slide Image Placeholder 1"/>
+          <p:cNvSpPr>
+            <a:spLocks noGrp="1" noRot="1" noChangeAspect="1"/>
+          </p:cNvSpPr>
+          <p:nvPr>
+            <p:ph type="sldImg"/>
+          </p:nvPr>
+        </p:nvSpPr>
+        <p:spPr/>
+      </p:sp>
+      <p:sp>
+        <p:nvSpPr>
+          <p:cNvPr id="3" name="Notes Placeholder 2"/>
+          <p:cNvSpPr>
+            <a:spLocks noGrp="1"/>
+          </p:cNvSpPr>
+          <p:nvPr>
+            <p:ph type="body" idx="1"/>
+          </p:nvPr>
+        </p:nvSpPr>
+        <p:spPr/>
+        <p:txBody>
+          <a:bodyPr/>
+          <a:lstStyle/>
+          <a:p>
+            <a:r>
+              <a:rPr lang="en-US" dirty="0"/>
+              <a:t>Anything not briefed by a shop. One line each.</a:t>
+            </a:r>
+            <a:endParaRPr lang="en-US" dirty="0"/>
+          </a:p>
+        </p:txBody>
+      </p:sp>
+      <p:sp>
+        <p:nvSpPr>
+          <p:cNvPr id="4" name="Slide Number Placeholder 3"/>
+          <p:cNvSpPr>
+            <a:spLocks noGrp="1"/>
+          </p:cNvSpPr>
+          <p:nvPr>
+            <p:ph type="sldNum" sz="quarter" idx="10"/>
+          </p:nvPr>
+        </p:nvSpPr>
+        <p:spPr/>
+        <p:txBody>
+          <a:bodyPr/>
+          <a:lstStyle/>
+          <a:p>
+            <a:fld id="{F7021451-1387-4CA6-816F-3879F97B5CBC}" type="slidenum">
+              <a:rPr lang="en-US"/>
+              <a:t>14</a:t>
+            </a:fld>
+            <a:endParaRPr lang="en-US"/>
+          </a:p>
+        </p:txBody>
+      </p:sp>
+    </p:spTree>
+    <p:extLst>
+      <p:ext uri="{BB962C8B-B14F-4D97-AF65-F5344CB8AC3E}">
+        <p14:creationId xmlns:p14="http://schemas.microsoft.com/office/powerpoint/2010/main" val="1024086991"/>
+      </p:ext>
+    </p:extLst>
+  </p:cSld>
+  <p:clrMapOvr>
+    <a:masterClrMapping/>
+  </p:clrMapOvr>
+</p:notes>
+</file>
+
+<file path=ppt/notesSlides/notesSlide15.xml><?xml version="1.0" encoding="utf-8"?>
+<p:notes xmlns:a="http://schemas.openxmlformats.org/drawingml/2006/main" xmlns:r="http://schemas.openxmlformats.org/officeDocument/2006/relationships" xmlns:p="http://schemas.openxmlformats.org/presentationml/2006/main">
+  <p:cSld>
+    <p:spTree>
+      <p:nvGrpSpPr>
+        <p:cNvPr id="1" name=""/>
+        <p:cNvGrpSpPr/>
+        <p:nvPr/>
+      </p:nvGrpSpPr>
+      <p:grpSpPr>
+        <a:xfrm>
+          <a:off x="0" y="0"/>
+          <a:ext cx="0" cy="0"/>
+          <a:chOff x="0" y="0"/>
+          <a:chExt cx="0" cy="0"/>
+        </a:xfrm>
+      </p:grpSpPr>
+      <p:sp>
+        <p:nvSpPr>
+          <p:cNvPr id="2" name="Slide Image Placeholder 1"/>
+          <p:cNvSpPr>
+            <a:spLocks noGrp="1" noRot="1" noChangeAspect="1"/>
+          </p:cNvSpPr>
+          <p:nvPr>
+            <p:ph type="sldImg"/>
+          </p:nvPr>
+        </p:nvSpPr>
+        <p:spPr/>
+      </p:sp>
+      <p:sp>
+        <p:nvSpPr>
+          <p:cNvPr id="3" name="Notes Placeholder 2"/>
+          <p:cNvSpPr>
+            <a:spLocks noGrp="1"/>
+          </p:cNvSpPr>
+          <p:nvPr>
+            <p:ph type="body" idx="1"/>
+          </p:nvPr>
+        </p:nvSpPr>
+        <p:spPr/>
+        <p:txBody>
+          <a:bodyPr/>
+          <a:lstStyle/>
+          <a:p>
+            <a:r>
+              <a:rPr lang="en-US" dirty="0"/>
+              <a:t>Hand the floor to the Company Commander. Capture guidance on the Status Tracker.</a:t>
+            </a:r>
+            <a:endParaRPr lang="en-US" dirty="0"/>
+          </a:p>
+        </p:txBody>
+      </p:sp>
+      <p:sp>
+        <p:nvSpPr>
+          <p:cNvPr id="4" name="Slide Number Placeholder 3"/>
+          <p:cNvSpPr>
+            <a:spLocks noGrp="1"/>
+          </p:cNvSpPr>
+          <p:nvPr>
+            <p:ph type="sldNum" sz="quarter" idx="10"/>
+          </p:nvPr>
+        </p:nvSpPr>
+        <p:spPr/>
+        <p:txBody>
+          <a:bodyPr/>
+          <a:lstStyle/>
+          <a:p>
+            <a:fld id="{F7021451-1387-4CA6-816F-3879F97B5CBC}" type="slidenum">
+              <a:rPr lang="en-US"/>
+              <a:t>15</a:t>
+            </a:fld>
+            <a:endParaRPr lang="en-US"/>
+          </a:p>
+        </p:txBody>
+      </p:sp>
+    </p:spTree>
+    <p:extLst>
+      <p:ext uri="{BB962C8B-B14F-4D97-AF65-F5344CB8AC3E}">
+        <p14:creationId xmlns:p14="http://schemas.microsoft.com/office/powerpoint/2010/main" val="1024086991"/>
+      </p:ext>
+    </p:extLst>
+  </p:cSld>
+  <p:clrMapOvr>
+    <a:masterClrMapping/>
+  </p:clrMapOvr>
+</p:notes>
+</file>
+
+<file path=ppt/notesSlides/notesSlide16.xml><?xml version="1.0" encoding="utf-8"?>
+<p:notes xmlns:a="http://schemas.openxmlformats.org/drawingml/2006/main" xmlns:r="http://schemas.openxmlformats.org/officeDocument/2006/relationships" xmlns:p="http://schemas.openxmlformats.org/presentationml/2006/main">
+  <p:cSld>
+    <p:spTree>
+      <p:nvGrpSpPr>
+        <p:cNvPr id="1" name=""/>
+        <p:cNvGrpSpPr/>
+        <p:nvPr/>
+      </p:nvGrpSpPr>
+      <p:grpSpPr>
+        <a:xfrm>
+          <a:off x="0" y="0"/>
+          <a:ext cx="0" cy="0"/>
+          <a:chOff x="0" y="0"/>
+          <a:chExt cx="0" cy="0"/>
+        </a:xfrm>
+      </p:grpSpPr>
+      <p:sp>
+        <p:nvSpPr>
+          <p:cNvPr id="2" name="Slide Image Placeholder 1"/>
+          <p:cNvSpPr>
+            <a:spLocks noGrp="1" noRot="1" noChangeAspect="1"/>
+          </p:cNvSpPr>
+          <p:nvPr>
+            <p:ph type="sldImg"/>
+          </p:nvPr>
+        </p:nvSpPr>
+        <p:spPr/>
+      </p:sp>
+      <p:sp>
+        <p:nvSpPr>
+          <p:cNvPr id="3" name="Notes Placeholder 2"/>
+          <p:cNvSpPr>
+            <a:spLocks noGrp="1"/>
+          </p:cNvSpPr>
+          <p:nvPr>
+            <p:ph type="body" idx="1"/>
+          </p:nvPr>
+        </p:nvSpPr>
+        <p:spPr/>
+        <p:txBody>
+          <a:bodyPr/>
+          <a:lstStyle/>
+          <a:p>
+            <a:r>
+              <a:rPr lang="en-US" dirty="0"/>
+              <a:t>Open floor. Record any new taskings on the Status Tracker.</a:t>
+            </a:r>
+            <a:endParaRPr lang="en-US" dirty="0"/>
+          </a:p>
+        </p:txBody>
+      </p:sp>
+      <p:sp>
+        <p:nvSpPr>
+          <p:cNvPr id="4" name="Slide Number Placeholder 3"/>
+          <p:cNvSpPr>
+            <a:spLocks noGrp="1"/>
+          </p:cNvSpPr>
+          <p:nvPr>
+            <p:ph type="sldNum" sz="quarter" idx="10"/>
+          </p:nvPr>
+        </p:nvSpPr>
+        <p:spPr/>
+        <p:txBody>
+          <a:bodyPr/>
+          <a:lstStyle/>
+          <a:p>
+            <a:fld id="{F7021451-1387-4CA6-816F-3879F97B5CBC}" type="slidenum">
+              <a:rPr lang="en-US"/>
+              <a:t>16</a:t>
             </a:fld>
             <a:endParaRPr lang="en-US"/>
           </a:p>
@@ -6703,8 +6970,8 @@
         </p:nvSpPr>
         <p:spPr>
           <a:xfrm>
-            <a:off x="502920" y="1280160"/>
-            <a:ext cx="5510632" cy="2043684"/>
+            <a:off x="502920" y="2423160"/>
+            <a:ext cx="11185855" cy="1737360"/>
           </a:xfrm>
           <a:prstGeom prst="rect">
             <a:avLst/>
@@ -6728,8 +6995,8 @@
         </p:nvSpPr>
         <p:spPr>
           <a:xfrm>
-            <a:off x="777240" y="1554480"/>
-            <a:ext cx="640080" cy="640080"/>
+            <a:off x="960120" y="2880360"/>
+            <a:ext cx="822960" cy="822960"/>
           </a:xfrm>
           <a:prstGeom prst="rect">
             <a:avLst/>
@@ -6747,7 +7014,7 @@
               <a:buNone/>
             </a:pPr>
             <a:r>
-              <a:rPr lang="en-US" sz="2800" b="1" dirty="0">
+              <a:rPr lang="en-US" sz="3400" b="1" dirty="0">
                 <a:solidFill>
                   <a:srgbClr val="FFFFFF"/>
                 </a:solidFill>
@@ -6757,7 +7024,7 @@
               </a:rPr>
               <a:t>1</a:t>
             </a:r>
-            <a:endParaRPr lang="en-US" sz="2800" dirty="0"/>
+            <a:endParaRPr lang="en-US" sz="3400" dirty="0"/>
           </a:p>
         </p:txBody>
       </p:sp>
@@ -6769,8 +7036,8 @@
         </p:nvSpPr>
         <p:spPr>
           <a:xfrm>
-            <a:off x="1600200" y="1508760"/>
-            <a:ext cx="4230472" cy="731520"/>
+            <a:off x="2148840" y="2788920"/>
+            <a:ext cx="9174175" cy="685800"/>
           </a:xfrm>
           <a:prstGeom prst="rect">
             <a:avLst/>
@@ -6786,7 +7053,7 @@
               <a:buNone/>
             </a:pPr>
             <a:r>
-              <a:rPr lang="en-US" sz="2800" b="1" dirty="0">
+              <a:rPr lang="en-US" sz="4000" b="1" dirty="0">
                 <a:solidFill>
                   <a:srgbClr val="000000"/>
                 </a:solidFill>
@@ -6796,7 +7063,7 @@
               </a:rPr>
               <a:t>TAC Cadre</a:t>
             </a:r>
-            <a:endParaRPr lang="en-US" sz="2800" dirty="0"/>
+            <a:endParaRPr lang="en-US" sz="4000" dirty="0"/>
           </a:p>
         </p:txBody>
       </p:sp>
@@ -6808,8 +7075,8 @@
         </p:nvSpPr>
         <p:spPr>
           <a:xfrm>
-            <a:off x="1600200" y="2240280"/>
-            <a:ext cx="4230472" cy="457200"/>
+            <a:off x="2148840" y="3474720"/>
+            <a:ext cx="9174175" cy="411480"/>
           </a:xfrm>
           <a:prstGeom prst="rect">
             <a:avLst/>
@@ -6825,7 +7092,7 @@
               <a:buNone/>
             </a:pPr>
             <a:r>
-              <a:rPr lang="en-US" sz="1400" dirty="0">
+              <a:rPr lang="en-US" sz="1600" dirty="0">
                 <a:solidFill>
                   <a:srgbClr val="1F4E2C"/>
                 </a:solidFill>
@@ -6835,20 +7102,86 @@
               </a:rPr>
               <a:t>Cadre remarks and guidance</a:t>
             </a:r>
-            <a:endParaRPr lang="en-US" sz="1400" dirty="0"/>
+            <a:endParaRPr lang="en-US" sz="1600" dirty="0"/>
           </a:p>
         </p:txBody>
       </p:sp>
-      <p:sp>
-        <p:nvSpPr>
-          <p:cNvPr id="8" name="Shape 5"/>
+    </p:spTree>
+  </p:cSld>
+  <p:clrMapOvr>
+    <a:masterClrMapping/>
+  </p:clrMapOvr>
+</p:sld>
+</file>
+
+<file path=ppt/slides/slide14.xml><?xml version="1.0" encoding="utf-8"?>
+<p:sld xmlns:a="http://schemas.openxmlformats.org/drawingml/2006/main" xmlns:r="http://schemas.openxmlformats.org/officeDocument/2006/relationships" xmlns:p="http://schemas.openxmlformats.org/presentationml/2006/main">
+  <p:cSld name="Slide 14">
+    <p:spTree>
+      <p:nvGrpSpPr>
+        <p:cNvPr id="1" name=""/>
+        <p:cNvGrpSpPr/>
+        <p:nvPr/>
+      </p:nvGrpSpPr>
+      <p:grpSpPr>
+        <a:xfrm>
+          <a:off x="0" y="0"/>
+          <a:ext cx="0" cy="0"/>
+          <a:chOff x="0" y="0"/>
+          <a:chExt cx="0" cy="0"/>
+        </a:xfrm>
+      </p:grpSpPr>
+      <p:sp>
+        <p:nvSpPr>
+          <p:cNvPr id="2" name="Text 6"/>
           <p:cNvSpPr/>
-          <p:nvPr/>
-        </p:nvSpPr>
-        <p:spPr>
-          <a:xfrm>
-            <a:off x="6178144" y="1280160"/>
-            <a:ext cx="5510632" cy="2043684"/>
+          <p:nvPr>
+            <p:ph idx="108" type="title" hasCustomPrompt="1"/>
+          </p:nvPr>
+        </p:nvSpPr>
+        <p:spPr>
+          <a:xfrm>
+            <a:off x="1188720" y="201168"/>
+            <a:ext cx="9814255" cy="713232"/>
+          </a:xfrm>
+          <a:prstGeom prst="rect">
+            <a:avLst/>
+          </a:prstGeom>
+          <a:noFill/>
+          <a:ln/>
+        </p:spPr>
+        <p:txBody>
+          <a:bodyPr wrap="square" lIns="0" tIns="0" rIns="0" bIns="0" rtlCol="0" anchor="ctr"/>
+          <a:lstStyle/>
+          <a:p>
+            <a:pPr algn="ctr" indent="0" marL="0">
+              <a:buNone/>
+            </a:pPr>
+            <a:r>
+              <a:rPr lang="en-US" sz="3600" b="1" dirty="0">
+                <a:solidFill>
+                  <a:srgbClr val="000000"/>
+                </a:solidFill>
+                <a:latin typeface="Arial" pitchFamily="34" charset="0"/>
+                <a:ea typeface="Arial" pitchFamily="34" charset="-122"/>
+                <a:cs typeface="Arial" pitchFamily="34" charset="-120"/>
+              </a:rPr>
+              <a:t>Closing</a:t>
+            </a:r>
+            <a:endParaRPr lang="en-US" sz="3600" dirty="0"/>
+          </a:p>
+        </p:txBody>
+      </p:sp>
+      <p:sp>
+        <p:nvSpPr>
+          <p:cNvPr id="4" name="Shape 1"/>
+          <p:cNvSpPr/>
+          <p:nvPr/>
+        </p:nvSpPr>
+        <p:spPr>
+          <a:xfrm>
+            <a:off x="502920" y="2423160"/>
+            <a:ext cx="11185855" cy="1737360"/>
           </a:xfrm>
           <a:prstGeom prst="rect">
             <a:avLst/>
@@ -6866,14 +7199,14 @@
       </p:sp>
       <p:sp>
         <p:nvSpPr>
-          <p:cNvPr id="9" name="Text 6"/>
+          <p:cNvPr id="5" name="Text 2"/>
           <p:cNvSpPr txBox="1"/>
           <p:nvPr/>
         </p:nvSpPr>
         <p:spPr>
           <a:xfrm>
-            <a:off x="6452464" y="1554480"/>
-            <a:ext cx="640080" cy="640080"/>
+            <a:off x="960120" y="2880360"/>
+            <a:ext cx="822960" cy="822960"/>
           </a:xfrm>
           <a:prstGeom prst="rect">
             <a:avLst/>
@@ -6891,7 +7224,7 @@
               <a:buNone/>
             </a:pPr>
             <a:r>
-              <a:rPr lang="en-US" sz="2800" b="1" dirty="0">
+              <a:rPr lang="en-US" sz="3400" b="1" dirty="0">
                 <a:solidFill>
                   <a:srgbClr val="FFFFFF"/>
                 </a:solidFill>
@@ -6901,20 +7234,20 @@
               </a:rPr>
               <a:t>2</a:t>
             </a:r>
-            <a:endParaRPr lang="en-US" sz="2800" dirty="0"/>
+            <a:endParaRPr lang="en-US" sz="3400" dirty="0"/>
           </a:p>
         </p:txBody>
       </p:sp>
       <p:sp>
         <p:nvSpPr>
-          <p:cNvPr id="10" name="Text 7"/>
+          <p:cNvPr id="6" name="Text 3"/>
           <p:cNvSpPr txBox="1"/>
           <p:nvPr/>
         </p:nvSpPr>
         <p:spPr>
           <a:xfrm>
-            <a:off x="7275424" y="1508760"/>
-            <a:ext cx="4230472" cy="731520"/>
+            <a:off x="2148840" y="2788920"/>
+            <a:ext cx="9174175" cy="685800"/>
           </a:xfrm>
           <a:prstGeom prst="rect">
             <a:avLst/>
@@ -6930,7 +7263,7 @@
               <a:buNone/>
             </a:pPr>
             <a:r>
-              <a:rPr lang="en-US" sz="2800" b="1" dirty="0">
+              <a:rPr lang="en-US" sz="4000" b="1" dirty="0">
                 <a:solidFill>
                   <a:srgbClr val="000000"/>
                 </a:solidFill>
@@ -6940,20 +7273,20 @@
               </a:rPr>
               <a:t>Alibis</a:t>
             </a:r>
-            <a:endParaRPr lang="en-US" sz="2800" dirty="0"/>
+            <a:endParaRPr lang="en-US" sz="4000" dirty="0"/>
           </a:p>
         </p:txBody>
       </p:sp>
       <p:sp>
         <p:nvSpPr>
-          <p:cNvPr id="11" name="Text 8"/>
+          <p:cNvPr id="7" name="Text 4"/>
           <p:cNvSpPr txBox="1"/>
           <p:nvPr/>
         </p:nvSpPr>
         <p:spPr>
           <a:xfrm>
-            <a:off x="7275424" y="2240280"/>
-            <a:ext cx="4230472" cy="457200"/>
+            <a:off x="2148840" y="3474720"/>
+            <a:ext cx="9174175" cy="411480"/>
           </a:xfrm>
           <a:prstGeom prst="rect">
             <a:avLst/>
@@ -6969,7 +7302,7 @@
               <a:buNone/>
             </a:pPr>
             <a:r>
-              <a:rPr lang="en-US" sz="1400" dirty="0">
+              <a:rPr lang="en-US" sz="1600" dirty="0">
                 <a:solidFill>
                   <a:srgbClr val="1F4E2C"/>
                 </a:solidFill>
@@ -6979,20 +7312,86 @@
               </a:rPr>
               <a:t>Outstanding items from the platoon</a:t>
             </a:r>
-            <a:endParaRPr lang="en-US" sz="1400" dirty="0"/>
+            <a:endParaRPr lang="en-US" sz="1600" dirty="0"/>
           </a:p>
         </p:txBody>
       </p:sp>
-      <p:sp>
-        <p:nvSpPr>
-          <p:cNvPr id="12" name="Shape 9"/>
+    </p:spTree>
+  </p:cSld>
+  <p:clrMapOvr>
+    <a:masterClrMapping/>
+  </p:clrMapOvr>
+</p:sld>
+</file>
+
+<file path=ppt/slides/slide15.xml><?xml version="1.0" encoding="utf-8"?>
+<p:sld xmlns:a="http://schemas.openxmlformats.org/drawingml/2006/main" xmlns:r="http://schemas.openxmlformats.org/officeDocument/2006/relationships" xmlns:p="http://schemas.openxmlformats.org/presentationml/2006/main">
+  <p:cSld name="Slide 15">
+    <p:spTree>
+      <p:nvGrpSpPr>
+        <p:cNvPr id="1" name=""/>
+        <p:cNvGrpSpPr/>
+        <p:nvPr/>
+      </p:nvGrpSpPr>
+      <p:grpSpPr>
+        <a:xfrm>
+          <a:off x="0" y="0"/>
+          <a:ext cx="0" cy="0"/>
+          <a:chOff x="0" y="0"/>
+          <a:chExt cx="0" cy="0"/>
+        </a:xfrm>
+      </p:grpSpPr>
+      <p:sp>
+        <p:nvSpPr>
+          <p:cNvPr id="2" name="Text 6"/>
           <p:cNvSpPr/>
-          <p:nvPr/>
-        </p:nvSpPr>
-        <p:spPr>
-          <a:xfrm>
-            <a:off x="502920" y="3488436"/>
-            <a:ext cx="5510632" cy="2043684"/>
+          <p:nvPr>
+            <p:ph idx="108" type="title" hasCustomPrompt="1"/>
+          </p:nvPr>
+        </p:nvSpPr>
+        <p:spPr>
+          <a:xfrm>
+            <a:off x="1188720" y="201168"/>
+            <a:ext cx="9814255" cy="713232"/>
+          </a:xfrm>
+          <a:prstGeom prst="rect">
+            <a:avLst/>
+          </a:prstGeom>
+          <a:noFill/>
+          <a:ln/>
+        </p:spPr>
+        <p:txBody>
+          <a:bodyPr wrap="square" lIns="0" tIns="0" rIns="0" bIns="0" rtlCol="0" anchor="ctr"/>
+          <a:lstStyle/>
+          <a:p>
+            <a:pPr algn="ctr" indent="0" marL="0">
+              <a:buNone/>
+            </a:pPr>
+            <a:r>
+              <a:rPr lang="en-US" sz="3600" b="1" dirty="0">
+                <a:solidFill>
+                  <a:srgbClr val="000000"/>
+                </a:solidFill>
+                <a:latin typeface="Arial" pitchFamily="34" charset="0"/>
+                <a:ea typeface="Arial" pitchFamily="34" charset="-122"/>
+                <a:cs typeface="Arial" pitchFamily="34" charset="-120"/>
+              </a:rPr>
+              <a:t>Closing</a:t>
+            </a:r>
+            <a:endParaRPr lang="en-US" sz="3600" dirty="0"/>
+          </a:p>
+        </p:txBody>
+      </p:sp>
+      <p:sp>
+        <p:nvSpPr>
+          <p:cNvPr id="4" name="Shape 1"/>
+          <p:cNvSpPr/>
+          <p:nvPr/>
+        </p:nvSpPr>
+        <p:spPr>
+          <a:xfrm>
+            <a:off x="502920" y="2423160"/>
+            <a:ext cx="11185855" cy="1737360"/>
           </a:xfrm>
           <a:prstGeom prst="rect">
             <a:avLst/>
@@ -7010,14 +7409,14 @@
       </p:sp>
       <p:sp>
         <p:nvSpPr>
-          <p:cNvPr id="13" name="Text 10"/>
+          <p:cNvPr id="5" name="Text 2"/>
           <p:cNvSpPr txBox="1"/>
           <p:nvPr/>
         </p:nvSpPr>
         <p:spPr>
           <a:xfrm>
-            <a:off x="777240" y="3762756"/>
-            <a:ext cx="640080" cy="640080"/>
+            <a:off x="960120" y="2880360"/>
+            <a:ext cx="822960" cy="822960"/>
           </a:xfrm>
           <a:prstGeom prst="rect">
             <a:avLst/>
@@ -7035,7 +7434,7 @@
               <a:buNone/>
             </a:pPr>
             <a:r>
-              <a:rPr lang="en-US" sz="2800" b="1" dirty="0">
+              <a:rPr lang="en-US" sz="3400" b="1" dirty="0">
                 <a:solidFill>
                   <a:srgbClr val="FFFFFF"/>
                 </a:solidFill>
@@ -7045,20 +7444,20 @@
               </a:rPr>
               <a:t>3</a:t>
             </a:r>
-            <a:endParaRPr lang="en-US" sz="2800" dirty="0"/>
+            <a:endParaRPr lang="en-US" sz="3400" dirty="0"/>
           </a:p>
         </p:txBody>
       </p:sp>
       <p:sp>
         <p:nvSpPr>
-          <p:cNvPr id="14" name="Text 11"/>
+          <p:cNvPr id="6" name="Text 3"/>
           <p:cNvSpPr txBox="1"/>
           <p:nvPr/>
         </p:nvSpPr>
         <p:spPr>
           <a:xfrm>
-            <a:off x="1600200" y="3717036"/>
-            <a:ext cx="4230472" cy="731520"/>
+            <a:off x="2148840" y="2788920"/>
+            <a:ext cx="9174175" cy="685800"/>
           </a:xfrm>
           <a:prstGeom prst="rect">
             <a:avLst/>
@@ -7074,7 +7473,7 @@
               <a:buNone/>
             </a:pPr>
             <a:r>
-              <a:rPr lang="en-US" sz="2800" b="1" dirty="0">
+              <a:rPr lang="en-US" sz="4000" b="1" dirty="0">
                 <a:solidFill>
                   <a:srgbClr val="000000"/>
                 </a:solidFill>
@@ -7084,20 +7483,20 @@
               </a:rPr>
               <a:t>Company Commander</a:t>
             </a:r>
-            <a:endParaRPr lang="en-US" sz="2800" dirty="0"/>
+            <a:endParaRPr lang="en-US" sz="4000" dirty="0"/>
           </a:p>
         </p:txBody>
       </p:sp>
       <p:sp>
         <p:nvSpPr>
-          <p:cNvPr id="15" name="Text 12"/>
+          <p:cNvPr id="7" name="Text 4"/>
           <p:cNvSpPr txBox="1"/>
           <p:nvPr/>
         </p:nvSpPr>
         <p:spPr>
           <a:xfrm>
-            <a:off x="1600200" y="4448556"/>
-            <a:ext cx="4230472" cy="457200"/>
+            <a:off x="2148840" y="3474720"/>
+            <a:ext cx="9174175" cy="411480"/>
           </a:xfrm>
           <a:prstGeom prst="rect">
             <a:avLst/>
@@ -7113,7 +7512,7 @@
               <a:buNone/>
             </a:pPr>
             <a:r>
-              <a:rPr lang="en-US" sz="1400" dirty="0">
+              <a:rPr lang="en-US" sz="1600" dirty="0">
                 <a:solidFill>
                   <a:srgbClr val="1F4E2C"/>
                 </a:solidFill>
@@ -7123,20 +7522,86 @@
               </a:rPr>
               <a:t>Commander's remarks and guidance</a:t>
             </a:r>
-            <a:endParaRPr lang="en-US" sz="1400" dirty="0"/>
+            <a:endParaRPr lang="en-US" sz="1600" dirty="0"/>
           </a:p>
         </p:txBody>
       </p:sp>
-      <p:sp>
-        <p:nvSpPr>
-          <p:cNvPr id="16" name="Shape 13"/>
+    </p:spTree>
+  </p:cSld>
+  <p:clrMapOvr>
+    <a:masterClrMapping/>
+  </p:clrMapOvr>
+</p:sld>
+</file>
+
+<file path=ppt/slides/slide16.xml><?xml version="1.0" encoding="utf-8"?>
+<p:sld xmlns:a="http://schemas.openxmlformats.org/drawingml/2006/main" xmlns:r="http://schemas.openxmlformats.org/officeDocument/2006/relationships" xmlns:p="http://schemas.openxmlformats.org/presentationml/2006/main">
+  <p:cSld name="Slide 16">
+    <p:spTree>
+      <p:nvGrpSpPr>
+        <p:cNvPr id="1" name=""/>
+        <p:cNvGrpSpPr/>
+        <p:nvPr/>
+      </p:nvGrpSpPr>
+      <p:grpSpPr>
+        <a:xfrm>
+          <a:off x="0" y="0"/>
+          <a:ext cx="0" cy="0"/>
+          <a:chOff x="0" y="0"/>
+          <a:chExt cx="0" cy="0"/>
+        </a:xfrm>
+      </p:grpSpPr>
+      <p:sp>
+        <p:nvSpPr>
+          <p:cNvPr id="2" name="Text 6"/>
           <p:cNvSpPr/>
-          <p:nvPr/>
-        </p:nvSpPr>
-        <p:spPr>
-          <a:xfrm>
-            <a:off x="6178144" y="3488436"/>
-            <a:ext cx="5510632" cy="2043684"/>
+          <p:nvPr>
+            <p:ph idx="108" type="title" hasCustomPrompt="1"/>
+          </p:nvPr>
+        </p:nvSpPr>
+        <p:spPr>
+          <a:xfrm>
+            <a:off x="1188720" y="201168"/>
+            <a:ext cx="9814255" cy="713232"/>
+          </a:xfrm>
+          <a:prstGeom prst="rect">
+            <a:avLst/>
+          </a:prstGeom>
+          <a:noFill/>
+          <a:ln/>
+        </p:spPr>
+        <p:txBody>
+          <a:bodyPr wrap="square" lIns="0" tIns="0" rIns="0" bIns="0" rtlCol="0" anchor="ctr"/>
+          <a:lstStyle/>
+          <a:p>
+            <a:pPr algn="ctr" indent="0" marL="0">
+              <a:buNone/>
+            </a:pPr>
+            <a:r>
+              <a:rPr lang="en-US" sz="3600" b="1" dirty="0">
+                <a:solidFill>
+                  <a:srgbClr val="000000"/>
+                </a:solidFill>
+                <a:latin typeface="Arial" pitchFamily="34" charset="0"/>
+                <a:ea typeface="Arial" pitchFamily="34" charset="-122"/>
+                <a:cs typeface="Arial" pitchFamily="34" charset="-120"/>
+              </a:rPr>
+              <a:t>Closing</a:t>
+            </a:r>
+            <a:endParaRPr lang="en-US" sz="3600" dirty="0"/>
+          </a:p>
+        </p:txBody>
+      </p:sp>
+      <p:sp>
+        <p:nvSpPr>
+          <p:cNvPr id="4" name="Shape 1"/>
+          <p:cNvSpPr/>
+          <p:nvPr/>
+        </p:nvSpPr>
+        <p:spPr>
+          <a:xfrm>
+            <a:off x="502920" y="2423160"/>
+            <a:ext cx="11185855" cy="1737360"/>
           </a:xfrm>
           <a:prstGeom prst="rect">
             <a:avLst/>
@@ -7154,14 +7619,14 @@
       </p:sp>
       <p:sp>
         <p:nvSpPr>
-          <p:cNvPr id="17" name="Text 14"/>
+          <p:cNvPr id="5" name="Text 2"/>
           <p:cNvSpPr txBox="1"/>
           <p:nvPr/>
         </p:nvSpPr>
         <p:spPr>
           <a:xfrm>
-            <a:off x="6452464" y="3762756"/>
-            <a:ext cx="640080" cy="640080"/>
+            <a:off x="960120" y="2880360"/>
+            <a:ext cx="822960" cy="822960"/>
           </a:xfrm>
           <a:prstGeom prst="rect">
             <a:avLst/>
@@ -7179,7 +7644,7 @@
               <a:buNone/>
             </a:pPr>
             <a:r>
-              <a:rPr lang="en-US" sz="2800" b="1" dirty="0">
+              <a:rPr lang="en-US" sz="3400" b="1" dirty="0">
                 <a:solidFill>
                   <a:srgbClr val="FFFFFF"/>
                 </a:solidFill>
@@ -7189,20 +7654,20 @@
               </a:rPr>
               <a:t>4</a:t>
             </a:r>
-            <a:endParaRPr lang="en-US" sz="2800" dirty="0"/>
+            <a:endParaRPr lang="en-US" sz="3400" dirty="0"/>
           </a:p>
         </p:txBody>
       </p:sp>
       <p:sp>
         <p:nvSpPr>
-          <p:cNvPr id="18" name="Text 15"/>
+          <p:cNvPr id="6" name="Text 3"/>
           <p:cNvSpPr txBox="1"/>
           <p:nvPr/>
         </p:nvSpPr>
         <p:spPr>
           <a:xfrm>
-            <a:off x="7275424" y="3717036"/>
-            <a:ext cx="4230472" cy="731520"/>
+            <a:off x="2148840" y="2788920"/>
+            <a:ext cx="9174175" cy="685800"/>
           </a:xfrm>
           <a:prstGeom prst="rect">
             <a:avLst/>
@@ -7218,7 +7683,7 @@
               <a:buNone/>
             </a:pPr>
             <a:r>
-              <a:rPr lang="en-US" sz="2800" b="1" dirty="0">
+              <a:rPr lang="en-US" sz="4000" b="1" dirty="0">
                 <a:solidFill>
                   <a:srgbClr val="000000"/>
                 </a:solidFill>
@@ -7228,7 +7693,46 @@
               </a:rPr>
               <a:t>Questions</a:t>
             </a:r>
-            <a:endParaRPr lang="en-US" sz="2800" dirty="0"/>
+            <a:endParaRPr lang="en-US" sz="4000" dirty="0"/>
+          </a:p>
+        </p:txBody>
+      </p:sp>
+      <p:sp>
+        <p:nvSpPr>
+          <p:cNvPr id="7" name="Text 4"/>
+          <p:cNvSpPr txBox="1"/>
+          <p:nvPr/>
+        </p:nvSpPr>
+        <p:spPr>
+          <a:xfrm>
+            <a:off x="2148840" y="3474720"/>
+            <a:ext cx="9174175" cy="411480"/>
+          </a:xfrm>
+          <a:prstGeom prst="rect">
+            <a:avLst/>
+          </a:prstGeom>
+          <a:noFill/>
+          <a:ln/>
+        </p:spPr>
+        <p:txBody>
+          <a:bodyPr wrap="square" lIns="0" tIns="0" rIns="0" bIns="0" rtlCol="0" anchor="t"/>
+          <a:lstStyle/>
+          <a:p>
+            <a:pPr indent="0" marL="0">
+              <a:buNone/>
+            </a:pPr>
+            <a:r>
+              <a:rPr lang="en-US" sz="1600" dirty="0">
+                <a:solidFill>
+                  <a:srgbClr val="1F4E2C"/>
+                </a:solidFill>
+                <a:latin typeface="Arial" pitchFamily="34" charset="0"/>
+                <a:ea typeface="Arial" pitchFamily="34" charset="-122"/>
+                <a:cs typeface="Arial" pitchFamily="34" charset="-120"/>
+              </a:rPr>
+              <a:t>Open floor</a:t>
+            </a:r>
+            <a:endParaRPr lang="en-US" sz="1600" dirty="0"/>
           </a:p>
         </p:txBody>
       </p:sp>
@@ -7545,7 +8049,7 @@
                 <a:ea typeface="Arial" pitchFamily="34" charset="-122"/>
                 <a:cs typeface="Arial" pitchFamily="34" charset="-120"/>
               </a:rPr>
-              <a:t>Closing: TAC Cadre | Alibis | Company Commander | Questions</a:t>
+              <a:t>TAC Cadre  |  Alibis  |  Company Commander  |  Questions</a:t>
             </a:r>
             <a:endParaRPr lang="en-US" sz="2000" dirty="0"/>
           </a:p>

</xml_diff>